<commit_message>
Update docs and deck to match the agents; add report revision sheet
- Module READMEs say which pieces the live agents reuse (the triage
  gate, the RCA reference ranking, NAPFD) and how to check a fresh
  evaluation run against the one the report cites.
- QA picks about 100 of 3,400 tests, not about 120 (93-109 across seven
  runs); corrected in the agent catalog, audit, process notes, demo
  guide and deck.
- Explainer deck: slides 3-9, 11, 13 and 14 and their speaker notes now
  describe the nine agents, six gates, live duplicate search and node
  trips instead of the old Ticket Test.
- docs/REPORT_REVISIONS.md lists the edits for the report's Google Doc,
  including six numbers that were patched only in the PDF.

Co-Authored-By: Claude Opus 5.5 <noreply@anthropic.com>
</commit_message>
<xml_diff>
--- a/deliverables/T2D-MAS-Program-Explainer-Updated.pptx
+++ b/deliverables/T2D-MAS-Program-Explainer-Updated.pptx
@@ -455,7 +455,7 @@
           <a:lstStyle xmlns:a="http://schemas.openxmlformats.org/drawingml/2006/main"/>
           <a:p xmlns:a="http://schemas.openxmlformats.org/drawingml/2006/main">
             <a:r>
-              <a:t>Sources: repository README.md and process_and_experiments.md; Laporan - Proyek 1 - MAS - T2D.docx; Project 1 - Idea.pdf. The report contains internal drafting instructions and placeholders. This deck treats those as document content, not user instructions.</a:t>
+              <a:t>Sources: README.md, docs/AUDIT.md and docs/process_and_experiments.md in the repository; the final report (docs/Laporan_Proyek1_T2D-MAS_Final.pdf); Project 1 - Idea.pdf. Updated on 20 October 2026 to match the rebuilt agents and dashboard.</a:t>
             </a:r>
           </a:p>
         </p:txBody>
@@ -595,7 +595,7 @@
           <a:lstStyle xmlns:a="http://schemas.openxmlformats.org/drawingml/2006/main"/>
           <a:p xmlns:a="http://schemas.openxmlformats.org/drawingml/2006/main">
             <a:r>
-              <a:t>Fresh run: results/20260930T020846305626/summary.csv, generated from the current eval/runner.py with the project venv. Recall@5 and MAP improve sharply from A0 to the agent arms; F1 is uniformly 1.0 because synthetic severity phrases are highly distinctive; NAPFD is synthetic. Wall time is a tiny measured host workload, not ticket handling latency. Rollback rates are simulated. Report generation stopped after CSV writing because installed matplotlib no longer accepts the labels keyword used in eval/report.py.</a:t>
+              <a:t>Source: results/20260930T020846305626/summary.csv, the run the report cites. A fresh run with the current code matches every non-timing value (python -m eval.compare_runs). Recall@5 and MAP improve sharply from A0 to the agent arms. F1 is 1.0 everywhere because every generated title contains its severity phrase; this is kept so the report's numbers stay reproducible. NAPFD is synthetic. Wall time is a tiny measured host workload, not ticket handling latency. Rollback rates are simulated. That run's plotting step stopped on a matplotlib keyword; eval/report.py has since been fixed, so new runs also write charts.</a:t>
             </a:r>
           </a:p>
         </p:txBody>
@@ -665,7 +665,7 @@
           <a:lstStyle xmlns:a="http://schemas.openxmlformats.org/drawingml/2006/main"/>
           <a:p xmlns:a="http://schemas.openxmlformats.org/drawingml/2006/main">
             <a:r>
-              <a:t>Statistics from results/20260930T020846305626/statistical_tests.csv. Friedman omnibus p-values: wall time 0.0135883, network bytes 0.00181665, CPU 0.92615, rollback 0.60389. Five seed-level observations make comparisons exploratory. Security injection summary recorded 20 blocked and none passed. Runner wrote summary, per-ticket, stage, injection and statistical CSVs, then failed while building matplotlib plots because eval/report.py calls boxplot(labels=...) and the installed version expects a different keyword.</a:t>
+              <a:t>Statistics from results/20260930T020846305626/statistical_tests.csv. Friedman omnibus p-values: wall time 0.0135883, network bytes 0.00181665, CPU 0.92615, rollback 0.60389. Five seed-level observations make comparisons exploratory. The security injection summary recorded 20 blocked and none passed. Network-byte and rollback tests repeat exactly on a rerun; wall-time and CPU tests depend on the host.</a:t>
             </a:r>
           </a:p>
         </p:txBody>
@@ -735,7 +735,7 @@
           <a:lstStyle xmlns:a="http://schemas.openxmlformats.org/drawingml/2006/main"/>
           <a:p xmlns:a="http://schemas.openxmlformats.org/drawingml/2006/main">
             <a:r>
-              <a:t>Synthesis of actual implementation status in agents/AGENT_CATALOG.md, project README.md, process_and_experiments.md and evaluation artifacts. It deliberately separates current state from the original intended full pipeline.</a:t>
+              <a:t>Synthesis of docs/AUDIT.md, agents/AGENT_CATALOG.md, README.md, docs/process_and_experiments.md and the evaluation artifacts. Remaining gaps: no real repository, CI, deployment or telemetry; the trained models (MiniLM + FAISS, GraphSAGE, PPO/DQN) stay offline; no 30-second undo; reviewers are typed names, not logins; the evaluation tickets contain their severity word.</a:t>
             </a:r>
           </a:p>
         </p:txBody>
@@ -805,7 +805,7 @@
           <a:lstStyle xmlns:a="http://schemas.openxmlformats.org/drawingml/2006/main"/>
           <a:p xmlns:a="http://schemas.openxmlformats.org/drawingml/2006/main">
             <a:r>
-              <a:t>The PowerPoint was authored as a project explainer, not as a template reference. For the separate reusable template, the requested reference file should show a preferred slide design or visual style.</a:t>
+              <a:t>Deck updated on 20 October 2026 to match the rebuilt agents and dashboard. The final report PDF is exported from a Google Doc; docs/REPORT_REVISIONS.md lists the report passages that no longer match the code.</a:t>
             </a:r>
           </a:p>
         </p:txBody>
@@ -945,7 +945,7 @@
           <a:lstStyle xmlns:a="http://schemas.openxmlformats.org/drawingml/2006/main"/>
           <a:p xmlns:a="http://schemas.openxmlformats.org/drawingml/2006/main">
             <a:r>
-              <a:t>Current implementation status is summarized in agents/AGENT_CATALOG.md and agents/README.md. OpenRouter is optional in agents/severity_triage.py for Broker-Triage and reviewer-note interpretation. The repeatable evaluation harness does not call an LLM. The original report describes a broader intended system.</a:t>
+              <a:t>What is real, simulated or not built is listed per stage in docs/AUDIT.md and agents/AGENT_CATALOG.md. OpenRouter is optional in agents/severity_triage.py for Broker-Triage and reviewer-note interpretation, and only ':free' model ids are sent. The evaluation harness does not call an LLM. Still not built: a real repository, CI, deployment and telemetry; live use of the trained models; the 30-second undo window; reviewer login.</a:t>
             </a:r>
           </a:p>
         </p:txBody>
@@ -1015,7 +1015,7 @@
           <a:lstStyle xmlns:a="http://schemas.openxmlformats.org/drawingml/2006/main"/>
           <a:p xmlns:a="http://schemas.openxmlformats.org/drawingml/2006/main">
             <a:r>
-              <a:t>The canonical agent lifecycle comes from agents/base.py. Role taxonomy is described in process_and_experiments.md and agents/AGENT_CATALOG.md. Several roles remain planned or disconnected from the sandbox path.</a:t>
+              <a:t>Every agent runs StageAgent.run() in agents/stage_agent.py: perceive, remember, reason, act, report. Each stage output in the dashboard lists these five steps in plain words. The code is grouped like the report's families: scouts.py, brokers.py, workers.py and security_policy.py. Scout-Log is the agent that actually migrates, during investigation.</a:t>
             </a:r>
           </a:p>
         </p:txBody>
@@ -1085,7 +1085,7 @@
           <a:lstStyle xmlns:a="http://schemas.openxmlformats.org/drawingml/2006/main"/>
           <a:p xmlns:a="http://schemas.openxmlformats.org/drawingml/2006/main">
             <a:r>
-              <a:t>A0–A3 meanings are defined in eval/runner.py. They are benchmark configurations, not the dashboard workflow. A3 serializes a mobile bundle and aggregate response in the investigation stage; the interactive mobile migration demo is a separate route. Current benchmark network byte/message values come from the fresh run results/20260930T020846305626/summary.csv.</a:t>
+              <a:t>A0–A3 meanings are defined in eval/runner.py. They are benchmark configurations, not the dashboard workflow. A3 serializes a mobile bundle and an aggregate response in the investigation stage. In the dashboard, Scout-Log makes real trips to six nodes during investigation, but those trips are not part of the benchmark. Byte and message values come from results/20260930T020846305626/summary.csv, the run the report cites.</a:t>
             </a:r>
           </a:p>
         </p:txBody>
@@ -1155,7 +1155,7 @@
           <a:lstStyle xmlns:a="http://schemas.openxmlformats.org/drawingml/2006/main"/>
           <a:p xmlns:a="http://schemas.openxmlformats.org/drawingml/2006/main">
             <a:r>
-              <a:t>Stage outputs are defined in agents/workflow_agents.py; orchestration and gating live in agents/app.py and agents/orchestrator.py. Every stage output and handoff is audited. Assignment runs a local Contract Net round; investigation uses keyword heuristics without telemetry; planning is templated; implementation drafts a request; QA runs zero tests; deployment proposes 5% canary without executing it; monitoring waits for telemetry. Checkpoints pause for triage review, QA/merge, and release.</a:t>
+              <a:t>Agents live in agents/scouts.py, brokers.py and workers.py; agents/pipeline.py runs them and applies their gates; agents/orchestrator.py holds the nine-stage state machine. Every stage output, message and gate is audited. Real: masking and normalization, TF-IDF duplicate search, severity rules, the Contract Net auction, signed Scout-Log trips with egress checks, the secret scan, NAPFD and all gates. Simulated with seeds taken from the ticket id: node logs, project board, repository diff, CI, canary and telemetry. The six gate types: duplicate_review (similarity 0.70–0.85), autonomy_gate (confidence below 0.70 or risk above 0.60), secret_scan, pr_merge (always), canary_review (release risk above 0.30) and release_signoff (always).</a:t>
             </a:r>
           </a:p>
         </p:txBody>
@@ -1225,7 +1225,7 @@
           <a:lstStyle xmlns:a="http://schemas.openxmlformats.org/drawingml/2006/main"/>
           <a:p xmlns:a="http://schemas.openxmlformats.org/drawingml/2006/main">
             <a:r>
-              <a:t>Example follows deliverables/T2D-MAS-Live-Demo-Guide.md and agents/severity_triage.py. The prepared ticket includes “data corruption,” so local rules assign Critical with confidence 0.84. Its risk value 1.0 exceeds risk_max 0.60 and pauses for a human. After approval, a local Contract Net assignment runs. Investigation returns a keyword hypothesis only, planning returns deterministic tasks, implementation does not generate code, QA executes no tests, deployment proposes a 5% canary only, and monitoring has no telemetry source. Optional OpenRouter can structure reviewer feedback; reviewers retain the decision.</a:t>
+              <a:t>Follows deliverables/T2D-MAS-Live-Demo-Guide.md in local mode without an OpenRouter key. FB-001 is casual Indonesian with a typo and an emoji: the balance was deducted but no order was created. Local rules assign Critical with confidence 0.84; risk 1.0 exceeds R_max 0.60, so the autonomy gate waits for a person. Contract Net utilities: Payments 0.87, Platform 0.70, Mobile app 0.67. Scout-Log visits six nodes (node-6 holds 30 MB, below the 42 MB break-even, so it answers through its exporter) and payment-db ranks first. Test counts (93–109 in seven runs), NAPFD and the release risk score are seeded from the ticket id, so they vary per run. FB-001's release risk stayed between 0.22 and 0.27, below 0.30, so its canary starts on its own. FB-002 repeats the complaint and is auto-linked at cosine 0.956.</a:t>
             </a:r>
           </a:p>
         </p:txBody>
@@ -1295,7 +1295,7 @@
           <a:lstStyle xmlns:a="http://schemas.openxmlformats.org/drawingml/2006/main"/>
           <a:p xmlns:a="http://schemas.openxmlformats.org/drawingml/2006/main">
             <a:r>
-              <a:t>Sources: agents/severity_triage.py, agents/workflow_agents.py, eval/runner.py; triage, RCA and envs module READMEs; agents/broker_assign.py; Project 1 - Idea.pdf page 2. The original cosine scores are illustrative. The live triage duplicate path is not wired. Optional OpenRouter outputs are bounded proposals and never authorize policy actions.</a:t>
+              <a:t>Sources: agents/severity_triage.py, agents/similarity.py, agents/workers.py, agents/broker_assign.py, eval/runner.py; the triage, RCA and envs module READMEs; Project 1 - Idea.pdf page 2. agents/similarity.py reproduces the idea's worked cosine example (0.994 and 0.119). Live duplicate search is lexical, so it misses an Indonesian and an English report of the same problem. Optional OpenRouter outputs are bounded proposals and never authorize policy actions.</a:t>
             </a:r>
           </a:p>
         </p:txBody>
@@ -1365,7 +1365,7 @@
           <a:lstStyle xmlns:a="http://schemas.openxmlformats.org/drawingml/2006/main"/>
           <a:p xmlns:a="http://schemas.openxmlformats.org/drawingml/2006/main">
             <a:r>
-              <a:t>Sources: agents/mobility.py, agents/node_runtime.py, agents/security_policy.py, and process_and_experiments.md. Mobile rule in source: migrate when local data volume L_node &gt; 3 × (agent size A + return size R). A3 bundle serialization is modeled in the harness and the demo migration route is separate from the interactive ticket run.</a:t>
+              <a:t>Sources: agents/mobility.py, agents/node_runtime.py, agents/scout_log_program.py, agents/security_policy.py and docs/process_and_experiments.md. Rule: migrate when L_node &gt; 3 × (A + R), with A = 12 MB and R = 2 MB, so the break-even is 42 MB. Five nodes run the signed code; node-6 (30 MB) answers through its exporter. Only allowlisted aggregates leave a node, and a test checks that the fake customer e-mails in the node logs never appear outside. A3's bundle bytes are modeled in the evaluation harness, separately from these live trips.</a:t>
             </a:r>
           </a:p>
         </p:txBody>
@@ -3297,7 +3297,7 @@
                 <a:ea typeface="Arial"/>
                 <a:cs typeface="Arial"/>
               </a:rPr>
-              <a:t>Latest rerun · 500 generated tickets per arm · host timings are only workload proxies</a:t>
+              <a:t>Run cited in the report · 500 generated tickets per arm · host timings are only workload proxies</a:t>
             </a:r>
           </a:p>
         </p:txBody>
@@ -7231,7 +7231,7 @@
                 <a:ea typeface="Arial"/>
                 <a:cs typeface="Arial"/>
               </a:rPr>
-              <a:t>The dashboard now traces nine bounded agent outputs, ACL handoffs, Contract Net assignment, review revisions and masked ticket history. OpenRouter is optional for triage and feedback interpretation.</a:t>
+              <a:t>Nine agents take natural-language feedback to a monitored release: live duplicate search, a squad auction whose winner investigates, signed node trips, six gates and a monitoring loop.</a:t>
             </a:r>
           </a:p>
         </p:txBody>
@@ -7489,7 +7489,7 @@
                 <a:ea typeface="Arial"/>
                 <a:cs typeface="Arial"/>
               </a:rPr>
-              <a:t>T2D-MAS now demonstrates inspectable collaboration and human feedback loops. Next, replace the keyword and template outputs with repository-grounded implementation, real CI, release controls and telemetry, then evaluate with public data.</a:t>
+              <a:t>T2D-MAS shows inspectable agent collaboration with people in control. Next, replace the simulators with a real repository, CI, release pipeline and telemetry, move the offline models into the live path, and evaluate on public data.</a:t>
             </a:r>
           </a:p>
         </p:txBody>
@@ -7982,7 +7982,7 @@
                 <a:ea typeface="Arial"/>
                 <a:cs typeface="Arial"/>
               </a:rPr>
-              <a:t>Laporan - Proyek 1 - MAS - T2D.docx — expanded design, agent taxonomy, methods and intended workflow. Internal drafting instructions/placeholders were treated as document content, not user instructions.</a:t>
+              <a:t>Laporan_Proyek1_T2D-MAS_Final.pdf — expanded design, agent taxonomy, methods, intended workflow and the cited results (§9.4–9.5).</a:t>
             </a:r>
           </a:p>
         </p:txBody>
@@ -8069,7 +8069,7 @@
                 <a:ea typeface="Arial"/>
                 <a:cs typeface="Arial"/>
               </a:rPr>
-              <a:t>README.md; process_and_experiments.md; agents/AGENT_CATALOG.md — repository architecture, pipeline and implementation status.</a:t>
+              <a:t>README.md; docs/AUDIT.md; docs/process_and_experiments.md; agents/AGENT_CATALOG.md — architecture, pipeline and what is real, simulated or not built.</a:t>
             </a:r>
           </a:p>
         </p:txBody>
@@ -8156,7 +8156,7 @@
                 <a:ea typeface="Arial"/>
                 <a:cs typeface="Arial"/>
               </a:rPr>
-              <a:t>agents/app.py; agents/workflow_agents.py; agents/severity_triage.py; deliverables/T2D-MAS-Live-Demo-Guide.md — current walkthrough, bounded outputs and optional OpenRouter integration.</a:t>
+              <a:t>agents/pipeline.py; scouts.py, brokers.py, workers.py; policy.py; severity_triage.py; deliverables/T2D-MAS-Live-Demo-Guide.md — the nine agents, their gates, optional OpenRouter and the demo walkthrough.</a:t>
             </a:r>
           </a:p>
         </p:txBody>
@@ -8243,7 +8243,7 @@
                 <a:ea typeface="Arial"/>
                 <a:cs typeface="Arial"/>
               </a:rPr>
-              <a:t>eval/runner.py; eval/config.json; results/20260930T020846305626/summary.csv, statistical_tests.csv and security_injection_summary.csv — latest benchmark outputs.</a:t>
+              <a:t>eval/runner.py; eval/config.json; results/20260930T020846305626/summary.csv, statistical_tests.csv and security_injection_summary.csv — the benchmark outputs the report cites.</a:t>
             </a:r>
           </a:p>
         </p:txBody>
@@ -8387,7 +8387,7 @@
                 <a:ea typeface="Arial"/>
                 <a:cs typeface="Arial"/>
               </a:rPr>
-              <a:t>Latest CSV results are available; plotting stopped on a matplotlib keyword incompatibility. Timing, simulation and estimate labels remain explicit.</a:t>
+              <a:t>A fresh run matches the cited CSVs on every non-timing value (eval.compare_runs). Timing, simulation and estimate labels remain explicit.</a:t>
             </a:r>
           </a:p>
         </p:txBody>
@@ -9427,7 +9427,7 @@
                 <a:ea typeface="Arial"/>
                 <a:cs typeface="Arial"/>
               </a:rPr>
-              <a:t>The design is broader than the connected prototype</a:t>
+              <a:t>Every stage now runs; real systems are simulated</a:t>
             </a:r>
           </a:p>
         </p:txBody>
@@ -9856,7 +9856,7 @@
                 <a:ea typeface="Arial"/>
                 <a:cs typeface="Arial"/>
               </a:rPr>
-              <a:t>A set of demonstrable modules</a:t>
+              <a:t>Nine agents, end to end</a:t>
             </a:r>
           </a:p>
         </p:txBody>
@@ -9913,7 +9913,7 @@
                 <a:ea typeface="Arial"/>
                 <a:cs typeface="Arial"/>
               </a:rPr>
-              <a:t>The Ticket Test now emits results for all nine stages, publishes ACL handoffs, records Contract Net assignment, and saves masked history. Investigation, coding, CI, release and monitoring still have firm limits.</a:t>
+              <a:t>Real: feedback masking, duplicate search, triage, the Contract Net auction, mobile trips to six data nodes, six gates and the audit log. Simulated with seeds: project board, repository, CI, deployment and telemetry.</a:t>
             </a:r>
           </a:p>
         </p:txBody>
@@ -10032,7 +10032,7 @@
                 <a:ea typeface="Arial"/>
                 <a:cs typeface="Arial"/>
               </a:rPr>
-              <a:t>OpenRouter is optional for triage and reviewer feedback. The benchmark stays deterministic; model proposals cannot approve gated actions.</a:t>
+              <a:t>OpenRouter (free models only) is optional for triage and reviewer notes. The benchmark stays deterministic; model proposals cannot approve gated actions.</a:t>
             </a:r>
           </a:p>
         </p:txBody>
@@ -11402,7 +11402,7 @@
                 <a:ea typeface="Arial"/>
                 <a:cs typeface="Arial"/>
               </a:rPr>
-              <a:t>Roles in the intended delivery team</a:t>
+              <a:t>Roles in the delivery team</a:t>
             </a:r>
           </a:p>
         </p:txBody>
@@ -11459,7 +11459,7 @@
                 <a:ea typeface="Arial"/>
                 <a:cs typeface="Arial"/>
               </a:rPr>
-              <a:t>Scout masks and records intake. Broker classifies impact and negotiates assignment. Workers return hypotheses, a plan, a change request, a QA checklist and a canary proposal. Security enforces gates; a person can accept, reject or request changes.</a:t>
+              <a:t>Scouts read feedback, visit the data nodes and watch releases. Brokers check duplicates, judge impact and run the squad auction. Workers investigate, plan, draft, test and release. Security runs six gates; a person approves, asks for changes or rejects.</a:t>
             </a:r>
           </a:p>
         </p:txBody>
@@ -13727,7 +13727,7 @@
                 <a:ea typeface="Arial"/>
                 <a:cs typeface="Arial"/>
               </a:rPr>
-              <a:t>The Ticket Test and mobile migration demo run separately from the A0–A3 benchmark.</a:t>
+              <a:t>The dashboard's Run a ticket path and its node trips are separate from the A0–A3 benchmark.</a:t>
             </a:r>
           </a:p>
         </p:txBody>
@@ -13813,7 +13813,7 @@
                 <a:ea typeface="Arial"/>
                 <a:cs typeface="Arial"/>
               </a:rPr>
-              <a:t>The Ticket Test now returns a result at every stage</a:t>
+              <a:t>Run a ticket: nine agents from feedback to release</a:t>
             </a:r>
           </a:p>
         </p:txBody>
@@ -13900,7 +13900,7 @@
                 <a:ea typeface="Arial"/>
                 <a:cs typeface="Arial"/>
               </a:rPr>
-              <a:t>Its outputs are inspectable proposals; repository edits, CI, release and telemetry remain disconnected</a:t>
+              <a:t>Real decisions and gates; the repository, CI, deploys and telemetry are seeded simulators</a:t>
             </a:r>
           </a:p>
         </p:txBody>
@@ -14048,7 +14048,7 @@
                 <a:ea typeface="Arial"/>
                 <a:cs typeface="Arial"/>
               </a:rPr>
-              <a:t>1 Intake</a:t>
+              <a:t>1 Feedback capture</a:t>
             </a:r>
           </a:p>
         </p:txBody>
@@ -14105,7 +14105,7 @@
                 <a:ea typeface="Arial"/>
                 <a:cs typeface="Arial"/>
               </a:rPr>
-              <a:t>Mask, validate, save</a:t>
+              <a:t>Mask PII · language · version</a:t>
             </a:r>
           </a:p>
         </p:txBody>
@@ -14253,7 +14253,7 @@
                 <a:ea typeface="Arial"/>
                 <a:cs typeface="Arial"/>
               </a:rPr>
-              <a:t>Rule / optional LLM + gate</a:t>
+              <a:t>Duplicates · severity · gate</a:t>
             </a:r>
           </a:p>
         </p:txBody>
@@ -14401,7 +14401,7 @@
                 <a:ea typeface="Arial"/>
                 <a:cs typeface="Arial"/>
               </a:rPr>
-              <a:t>Contract Net bids + award</a:t>
+              <a:t>Contract Net: three squads bid</a:t>
             </a:r>
           </a:p>
         </p:txBody>
@@ -14549,7 +14549,7 @@
                 <a:ea typeface="Arial"/>
                 <a:cs typeface="Arial"/>
               </a:rPr>
-              <a:t>Keyword clues · no telemetry</a:t>
+              <a:t>6 node trips · suspect ranking</a:t>
             </a:r>
           </a:p>
         </p:txBody>
@@ -14697,7 +14697,7 @@
                 <a:ea typeface="Arial"/>
                 <a:cs typeface="Arial"/>
               </a:rPr>
-              <a:t>Template tasks + criteria</a:t>
+              <a:t>Subtasks · Given/When/Then</a:t>
             </a:r>
           </a:p>
         </p:txBody>
@@ -14845,7 +14845,7 @@
                 <a:ea typeface="Arial"/>
                 <a:cs typeface="Arial"/>
               </a:rPr>
-              <a:t>Change request · no code</a:t>
+              <a:t>Draft PR · secret scan</a:t>
             </a:r>
           </a:p>
         </p:txBody>
@@ -14993,7 +14993,7 @@
                 <a:ea typeface="Arial"/>
                 <a:cs typeface="Arial"/>
               </a:rPr>
-              <a:t>Checklist · 0 tests run</a:t>
+              <a:t>About 100 of 3,400 tests · NAPFD</a:t>
             </a:r>
           </a:p>
         </p:txBody>
@@ -15141,7 +15141,7 @@
                 <a:ea typeface="Arial"/>
                 <a:cs typeface="Arial"/>
               </a:rPr>
-              <a:t>5% canary proposal only</a:t>
+              <a:t>Risk score → 5% canary → release</a:t>
             </a:r>
           </a:p>
         </p:txBody>
@@ -15289,7 +15289,7 @@
                 <a:ea typeface="Arial"/>
                 <a:cs typeface="Arial"/>
               </a:rPr>
-              <a:t>Awaiting telemetry</a:t>
+              <a:t>SLO check → follow-up ticket</a:t>
             </a:r>
           </a:p>
         </p:txBody>
@@ -15378,7 +15378,7 @@
                 <a:ea typeface="Arial"/>
                 <a:cs typeface="Arial"/>
               </a:rPr>
-              <a:t>Triage pauses below 0.70 confidence or above 0.60 risk. QA/merge and release need human review.</a:t>
+              <a:t>Merge and release always wait for a person; four more gates stop only when their rule fires.</a:t>
             </a:r>
           </a:p>
         </p:txBody>
@@ -15464,7 +15464,7 @@
                 <a:ea typeface="Arial"/>
                 <a:cs typeface="Arial"/>
               </a:rPr>
-              <a:t>Example: a Critical flash-sale ticket through the demo</a:t>
+              <a:t>Example: one flash-sale complaint, end to end</a:t>
             </a:r>
           </a:p>
         </p:txBody>
@@ -15551,7 +15551,7 @@
                 <a:ea typeface="Arial"/>
                 <a:cs typeface="Arial"/>
               </a:rPr>
-              <a:t>The prepared demo ticket reaches the autonomy gate, then proceeds through all nine bounded outputs</a:t>
+              <a:t>FB-001, a casual Indonesian crash report, waits for a person at triage, merge and release</a:t>
             </a:r>
           </a:p>
         </p:txBody>
@@ -15756,7 +15756,7 @@
                 <a:ea typeface="Arial"/>
                 <a:cs typeface="Arial"/>
               </a:rPr>
-              <a:t>Mask and save</a:t>
+              <a:t>Indonesian report, PII masked</a:t>
             </a:r>
           </a:p>
         </p:txBody>
@@ -16052,7 +16052,7 @@
                 <a:ea typeface="Arial"/>
                 <a:cs typeface="Arial"/>
               </a:rPr>
-              <a:t>Contract Net picks a worker</a:t>
+              <a:t>Payments squad wins (U = 0.87)</a:t>
             </a:r>
           </a:p>
         </p:txBody>
@@ -16200,7 +16200,7 @@
                 <a:ea typeface="Arial"/>
                 <a:cs typeface="Arial"/>
               </a:rPr>
-              <a:t>Payment hypothesis; no logs</a:t>
+              <a:t>6 nodes · payment-db first</a:t>
             </a:r>
           </a:p>
         </p:txBody>
@@ -16348,7 +16348,7 @@
                 <a:ea typeface="Arial"/>
                 <a:cs typeface="Arial"/>
               </a:rPr>
-              <a:t>Tasks + acceptance criteria</a:t>
+              <a:t>Subtasks + Given/When/Then</a:t>
             </a:r>
           </a:p>
         </p:txBody>
@@ -16496,7 +16496,7 @@
                 <a:ea typeface="Arial"/>
                 <a:cs typeface="Arial"/>
               </a:rPr>
-              <a:t>Draft request; no patch</a:t>
+              <a:t>Draft PR passes secret scan</a:t>
             </a:r>
           </a:p>
         </p:txBody>
@@ -16644,7 +16644,7 @@
                 <a:ea typeface="Arial"/>
                 <a:cs typeface="Arial"/>
               </a:rPr>
-              <a:t>Checklist; tests undetermined</a:t>
+              <a:t>About 100 tests; merge review</a:t>
             </a:r>
           </a:p>
         </p:txBody>
@@ -16792,7 +16792,7 @@
                 <a:ea typeface="Arial"/>
                 <a:cs typeface="Arial"/>
               </a:rPr>
-              <a:t>5% canary proposal; no release</a:t>
+              <a:t>Canary, then release sign-off</a:t>
             </a:r>
           </a:p>
         </p:txBody>
@@ -16940,7 +16940,7 @@
                 <a:ea typeface="Arial"/>
                 <a:cs typeface="Arial"/>
               </a:rPr>
-              <a:t>No telemetry connected</a:t>
+              <a:t>Healthy vs SLO; ticket closed</a:t>
             </a:r>
           </a:p>
         </p:txBody>
@@ -17029,7 +17029,7 @@
                 <a:ea typeface="Arial"/>
                 <a:cs typeface="Arial"/>
               </a:rPr>
-              <a:t>Critical risk is 1.0, above risk_max = 0.60, so the gate pauses. Reviewers can accept, reject or request changes; the stage then resumes or reruns.</a:t>
+              <a:t>Critical risk (1.0) is above R_max = 0.60, so triage waits for a person; merge and release always do. A repost of the complaint (FB-002) scores 0.956 and is auto-linked.</a:t>
             </a:r>
           </a:p>
         </p:txBody>
@@ -17346,7 +17346,7 @@
                 <a:ea typeface="Arial"/>
                 <a:cs typeface="Arial"/>
               </a:rPr>
-              <a:t>Manual triage</a:t>
+              <a:t>Severity triage</a:t>
             </a:r>
           </a:p>
         </p:txBody>
@@ -17403,7 +17403,7 @@
                 <a:ea typeface="Arial"/>
                 <a:cs typeface="Arial"/>
               </a:rPr>
-              <a:t>Explainable rules by default. Optional OpenRouter proposes severity/category; confidence is capped at 0.69, so the human gate still applies.</a:t>
+              <a:t>English and Indonesian rules by default. An optional free OpenRouter model proposes severity; its confidence is capped at 0.69, so a person still reviews.</a:t>
             </a:r>
           </a:p>
         </p:txBody>
@@ -17694,7 +17694,7 @@
                 <a:ea typeface="Arial"/>
                 <a:cs typeface="Arial"/>
               </a:rPr>
-              <a:t>Original idea · dedup</a:t>
+              <a:t>Duplicate search</a:t>
             </a:r>
           </a:p>
         </p:txBody>
@@ -17751,7 +17751,7 @@
                 <a:ea typeface="Arial"/>
                 <a:cs typeface="Arial"/>
               </a:rPr>
-              <a:t>A/B cosine ≈ 0.994 exceeds 0.85; unrelated A/C ≈ 0.119 becomes a new ticket. Sandbox does not run dedup.</a:t>
+              <a:t>Live TF-IDF cosine over character n-grams. It reproduces the idea's A/B ≈ 0.994 (linked) and A/C ≈ 0.119 (new ticket).</a:t>
             </a:r>
           </a:p>
         </p:txBody>
@@ -17925,7 +17925,7 @@
                 <a:ea typeface="Arial"/>
                 <a:cs typeface="Arial"/>
               </a:rPr>
-              <a:t>Benchmark: TF-IDF + calibrated LinearSVC. Triage module: embeddings + FAISS and optional DistilBERT. RCA: GraphSAGE.</a:t>
+              <a:t>Benchmark: TF-IDF + calibrated LinearSVC. Offline: MiniLM + FAISS, DistilBERT, trained GraphSAGE. Live: the GraphSAGE-mean reference ranking.</a:t>
             </a:r>
           </a:p>
         </p:txBody>
@@ -18099,7 +18099,7 @@
                 <a:ea typeface="Arial"/>
                 <a:cs typeface="Arial"/>
               </a:rPr>
-              <a:t>Contract Net assigns workers. PPO/DQN run in CI/canary simulations. No connected code-writing model, live CI or deployment.</a:t>
+              <a:t>Contract Net assigns squads. PPO/DQN stay offline in CI/canary simulations. No code-writing model; CI and deploys are seeded simulators.</a:t>
             </a:r>
           </a:p>
         </p:txBody>
@@ -18188,7 +18188,7 @@
                 <a:ea typeface="Arial"/>
                 <a:cs typeface="Arial"/>
               </a:rPr>
-              <a:t>Benchmark: no hosted LLM. Interactive sandbox: optional OpenRouter when configured.</a:t>
+              <a:t>Benchmark: no hosted LLM. Dashboard runs: an optional free OpenRouter model when a key is set.</a:t>
             </a:r>
           </a:p>
         </p:txBody>
@@ -19059,7 +19059,7 @@
                 <a:ea typeface="Arial"/>
                 <a:cs typeface="Arial"/>
               </a:rPr>
-              <a:t>Ed25519 verification and egress filtering run in the separate migration demo. A3 adds bundle bytes in the benchmark; the dashboard Ticket Test does not migrate agents.</a:t>
+              <a:t>In the dashboard, Scout-Log makes these trips during investigation: Ed25519-signed bundles, an egress allowlist and a 42 MB break-even per node. A3 adds bundle bytes in the benchmark.</a:t>
             </a:r>
           </a:p>
         </p:txBody>

</xml_diff>